<commit_message>
lots of additional material
</commit_message>
<xml_diff>
--- a/r_graphics/ggplot2_vs_tidyplots_slides.pptx
+++ b/r_graphics/ggplot2_vs_tidyplots_slides.pptx
@@ -13,9 +13,10 @@
     <p:sldId id="261" r:id="rId7"/>
     <p:sldId id="262" r:id="rId8"/>
     <p:sldId id="263" r:id="rId9"/>
+    <p:sldId id="264" r:id="rId10"/>
   </p:sldIdLst>
   <p:notesMasterIdLst>
-    <p:notesMasterId r:id="rId10"/>
+    <p:notesMasterId r:id="rId11"/>
   </p:notesMasterIdLst>
   <p:sldSz cx="12192000" cy="6858000"/>
   <p:notesSz cx="6858000" cy="12192000"/>
@@ -1149,6 +1150,94 @@
             <a:fld id="{F7021451-1387-4CA6-816F-3879F97B5CBC}" type="slidenum">
               <a:rPr lang="en-US"/>
               <a:t>8</a:t>
+            </a:fld>
+            <a:endParaRPr lang="en-US"/>
+          </a:p>
+        </p:txBody>
+      </p:sp>
+    </p:spTree>
+    <p:extLst>
+      <p:ext uri="{BB962C8B-B14F-4D97-AF65-F5344CB8AC3E}">
+        <p14:creationId xmlns:p14="http://schemas.microsoft.com/office/powerpoint/2010/main" val="1024086991"/>
+      </p:ext>
+    </p:extLst>
+  </p:cSld>
+  <p:clrMapOvr>
+    <a:masterClrMapping/>
+  </p:clrMapOvr>
+</p:notes>
+</file>
+
+<file path=ppt/notesSlides/notesSlide9.xml><?xml version="1.0" encoding="utf-8"?>
+<p:notes xmlns:a="http://schemas.openxmlformats.org/drawingml/2006/main" xmlns:r="http://schemas.openxmlformats.org/officeDocument/2006/relationships" xmlns:p="http://schemas.openxmlformats.org/presentationml/2006/main">
+  <p:cSld>
+    <p:spTree>
+      <p:nvGrpSpPr>
+        <p:cNvPr id="1" name=""/>
+        <p:cNvGrpSpPr/>
+        <p:nvPr/>
+      </p:nvGrpSpPr>
+      <p:grpSpPr>
+        <a:xfrm>
+          <a:off x="0" y="0"/>
+          <a:ext cx="0" cy="0"/>
+          <a:chOff x="0" y="0"/>
+          <a:chExt cx="0" cy="0"/>
+        </a:xfrm>
+      </p:grpSpPr>
+      <p:sp>
+        <p:nvSpPr>
+          <p:cNvPr id="2" name="Slide Image Placeholder 1"/>
+          <p:cNvSpPr>
+            <a:spLocks noGrp="1" noRot="1" noChangeAspect="1"/>
+          </p:cNvSpPr>
+          <p:nvPr>
+            <p:ph type="sldImg"/>
+          </p:nvPr>
+        </p:nvSpPr>
+        <p:spPr/>
+      </p:sp>
+      <p:sp>
+        <p:nvSpPr>
+          <p:cNvPr id="3" name="Notes Placeholder 2"/>
+          <p:cNvSpPr>
+            <a:spLocks noGrp="1"/>
+          </p:cNvSpPr>
+          <p:nvPr>
+            <p:ph type="body" idx="1"/>
+          </p:nvPr>
+        </p:nvSpPr>
+        <p:spPr/>
+        <p:txBody>
+          <a:bodyPr/>
+          <a:lstStyle/>
+          <a:p>
+            <a:r>
+              <a:rPr lang="en-US" dirty="0"/>
+              <a:t/>
+            </a:r>
+            <a:endParaRPr lang="en-US" dirty="0"/>
+          </a:p>
+        </p:txBody>
+      </p:sp>
+      <p:sp>
+        <p:nvSpPr>
+          <p:cNvPr id="4" name="Slide Number Placeholder 3"/>
+          <p:cNvSpPr>
+            <a:spLocks noGrp="1"/>
+          </p:cNvSpPr>
+          <p:nvPr>
+            <p:ph type="sldNum" sz="quarter" idx="10"/>
+          </p:nvPr>
+        </p:nvSpPr>
+        <p:spPr/>
+        <p:txBody>
+          <a:bodyPr/>
+          <a:lstStyle/>
+          <a:p>
+            <a:fld id="{F7021451-1387-4CA6-816F-3879F97B5CBC}" type="slidenum">
+              <a:rPr lang="en-US"/>
+              <a:t>9</a:t>
             </a:fld>
             <a:endParaRPr lang="en-US"/>
           </a:p>
@@ -8851,6 +8940,782 @@
 </p:sld>
 </file>
 
+<file path=ppt/slides/slide9.xml><?xml version="1.0" encoding="utf-8"?>
+<p:sld xmlns:a="http://schemas.openxmlformats.org/drawingml/2006/main" xmlns:r="http://schemas.openxmlformats.org/officeDocument/2006/relationships" xmlns:p="http://schemas.openxmlformats.org/presentationml/2006/main">
+  <p:cSld name="Slide 9">
+    <p:bg>
+      <p:bgPr>
+        <a:solidFill>
+          <a:srgbClr val="FFFFFF"/>
+        </a:solidFill>
+      </p:bgPr>
+    </p:bg>
+    <p:spTree>
+      <p:nvGrpSpPr>
+        <p:cNvPr id="1" name=""/>
+        <p:cNvGrpSpPr/>
+        <p:nvPr/>
+      </p:nvGrpSpPr>
+      <p:grpSpPr>
+        <a:xfrm>
+          <a:off x="0" y="0"/>
+          <a:ext cx="0" cy="0"/>
+          <a:chOff x="0" y="0"/>
+          <a:chExt cx="0" cy="0"/>
+        </a:xfrm>
+      </p:grpSpPr>
+      <p:sp>
+        <p:nvSpPr>
+          <p:cNvPr id="2" name="Shape 0"/>
+          <p:cNvSpPr/>
+          <p:nvPr/>
+        </p:nvSpPr>
+        <p:spPr>
+          <a:xfrm>
+            <a:off x="548640" y="384048"/>
+            <a:ext cx="566928" cy="566928"/>
+          </a:xfrm>
+          <a:prstGeom prst="ellipse">
+            <a:avLst/>
+          </a:prstGeom>
+          <a:solidFill>
+            <a:srgbClr val="3B4A8C"/>
+          </a:solidFill>
+          <a:ln/>
+          <a:effectLst>
+            <a:outerShdw sx="100000" sy="100000" kx="0" ky="0" algn="bl" rotWithShape="0" blurRad="88900" dist="38100" dir="5400000">
+              <a:srgbClr val="000000">
+                <a:alpha val="12000"/>
+              </a:srgbClr>
+            </a:outerShdw>
+          </a:effectLst>
+        </p:spPr>
+      </p:sp>
+      <p:pic>
+        <p:nvPicPr>
+          <p:cNvPr id="3" name="Image 0" descr="preencoded.png">    </p:cNvPr>
+          <p:cNvPicPr>
+            <a:picLocks noChangeAspect="1"/>
+          </p:cNvPicPr>
+          <p:nvPr/>
+        </p:nvPicPr>
+        <p:blipFill>
+          <a:blip r:embed="rId1"/>
+          <a:stretch>
+            <a:fillRect/>
+          </a:stretch>
+        </p:blipFill>
+        <p:spPr>
+          <a:xfrm>
+            <a:off x="685800" y="521208"/>
+            <a:ext cx="292608" cy="292608"/>
+          </a:xfrm>
+          <a:prstGeom prst="rect">
+            <a:avLst/>
+          </a:prstGeom>
+        </p:spPr>
+      </p:pic>
+      <p:sp>
+        <p:nvSpPr>
+          <p:cNvPr id="4" name="Text 1"/>
+          <p:cNvSpPr/>
+          <p:nvPr/>
+        </p:nvSpPr>
+        <p:spPr>
+          <a:xfrm>
+            <a:off x="1298448" y="365760"/>
+            <a:ext cx="10058400" cy="274320"/>
+          </a:xfrm>
+          <a:prstGeom prst="rect">
+            <a:avLst/>
+          </a:prstGeom>
+          <a:noFill/>
+          <a:ln/>
+        </p:spPr>
+        <p:txBody>
+          <a:bodyPr wrap="square" lIns="0" tIns="0" rIns="0" bIns="0" rtlCol="0" anchor="ctr"/>
+          <a:lstStyle/>
+          <a:p>
+            <a:pPr indent="0" marL="0">
+              <a:buNone/>
+            </a:pPr>
+            <a:r>
+              <a:rPr lang="en-US" sz="1100" b="1" spc="200" kern="0" dirty="0">
+                <a:solidFill>
+                  <a:srgbClr val="838BA0"/>
+                </a:solidFill>
+                <a:latin typeface="Calibri" pitchFamily="34" charset="0"/>
+                <a:ea typeface="Calibri" pitchFamily="34" charset="-122"/>
+                <a:cs typeface="Calibri" pitchFamily="34" charset="-120"/>
+              </a:rPr>
+              <a:t>GOING DEEPER</a:t>
+            </a:r>
+            <a:endParaRPr lang="en-US" sz="1100" dirty="0"/>
+          </a:p>
+        </p:txBody>
+      </p:sp>
+      <p:sp>
+        <p:nvSpPr>
+          <p:cNvPr id="5" name="Text 2"/>
+          <p:cNvSpPr/>
+          <p:nvPr/>
+        </p:nvSpPr>
+        <p:spPr>
+          <a:xfrm>
+            <a:off x="1298448" y="603504"/>
+            <a:ext cx="10332720" cy="566928"/>
+          </a:xfrm>
+          <a:prstGeom prst="rect">
+            <a:avLst/>
+          </a:prstGeom>
+          <a:noFill/>
+          <a:ln/>
+        </p:spPr>
+        <p:txBody>
+          <a:bodyPr wrap="square" lIns="0" tIns="0" rIns="0" bIns="0" rtlCol="0" anchor="ctr"/>
+          <a:lstStyle/>
+          <a:p>
+            <a:pPr indent="0" marL="0">
+              <a:buNone/>
+            </a:pPr>
+            <a:r>
+              <a:rPr lang="en-US" sz="2700" b="1" dirty="0">
+                <a:solidFill>
+                  <a:srgbClr val="1E2336"/>
+                </a:solidFill>
+                <a:latin typeface="Cambria" pitchFamily="34" charset="0"/>
+                <a:ea typeface="Cambria" pitchFamily="34" charset="-122"/>
+                <a:cs typeface="Cambria" pitchFamily="34" charset="-120"/>
+              </a:rPr>
+              <a:t>References for low-level plotting functions</a:t>
+            </a:r>
+            <a:endParaRPr lang="en-US" sz="2700" dirty="0"/>
+          </a:p>
+        </p:txBody>
+      </p:sp>
+      <p:sp>
+        <p:nvSpPr>
+          <p:cNvPr id="6" name="Shape 3"/>
+          <p:cNvSpPr/>
+          <p:nvPr/>
+        </p:nvSpPr>
+        <p:spPr>
+          <a:xfrm>
+            <a:off x="548640" y="1371600"/>
+            <a:ext cx="11064240" cy="1783080"/>
+          </a:xfrm>
+          <a:prstGeom prst="roundRect">
+            <a:avLst>
+              <a:gd name="adj" fmla="val 4615"/>
+            </a:avLst>
+          </a:prstGeom>
+          <a:solidFill>
+            <a:srgbClr val="EDEFF8"/>
+          </a:solidFill>
+          <a:ln/>
+          <a:effectLst>
+            <a:outerShdw sx="100000" sy="100000" kx="0" ky="0" algn="bl" rotWithShape="0" blurRad="88900" dist="38100" dir="5400000">
+              <a:srgbClr val="000000">
+                <a:alpha val="12000"/>
+              </a:srgbClr>
+            </a:outerShdw>
+          </a:effectLst>
+        </p:spPr>
+      </p:sp>
+      <p:sp>
+        <p:nvSpPr>
+          <p:cNvPr id="7" name="Shape 4"/>
+          <p:cNvSpPr/>
+          <p:nvPr/>
+        </p:nvSpPr>
+        <p:spPr>
+          <a:xfrm>
+            <a:off x="822960" y="1572768"/>
+            <a:ext cx="640080" cy="384048"/>
+          </a:xfrm>
+          <a:prstGeom prst="roundRect">
+            <a:avLst>
+              <a:gd name="adj" fmla="val 50000"/>
+            </a:avLst>
+          </a:prstGeom>
+          <a:solidFill>
+            <a:srgbClr val="3B4A8C"/>
+          </a:solidFill>
+          <a:ln/>
+        </p:spPr>
+      </p:sp>
+      <p:sp>
+        <p:nvSpPr>
+          <p:cNvPr id="8" name="Text 5"/>
+          <p:cNvSpPr/>
+          <p:nvPr/>
+        </p:nvSpPr>
+        <p:spPr>
+          <a:xfrm>
+            <a:off x="822960" y="1572768"/>
+            <a:ext cx="640080" cy="384048"/>
+          </a:xfrm>
+          <a:prstGeom prst="rect">
+            <a:avLst/>
+          </a:prstGeom>
+          <a:noFill/>
+          <a:ln/>
+        </p:spPr>
+        <p:txBody>
+          <a:bodyPr wrap="square" lIns="0" tIns="0" rIns="0" bIns="0" rtlCol="0" anchor="ctr"/>
+          <a:lstStyle/>
+          <a:p>
+            <a:pPr algn="ctr" indent="0" marL="0">
+              <a:buNone/>
+            </a:pPr>
+            <a:r>
+              <a:rPr lang="en-US" sz="1300" b="1" dirty="0">
+                <a:solidFill>
+                  <a:srgbClr val="FFFFFF"/>
+                </a:solidFill>
+                <a:latin typeface="Courier New" pitchFamily="34" charset="0"/>
+                <a:ea typeface="Courier New" pitchFamily="34" charset="-122"/>
+                <a:cs typeface="Courier New" pitchFamily="34" charset="-120"/>
+              </a:rPr>
+              <a:t>grid</a:t>
+            </a:r>
+            <a:endParaRPr lang="en-US" sz="1300" dirty="0"/>
+          </a:p>
+        </p:txBody>
+      </p:sp>
+      <p:sp>
+        <p:nvSpPr>
+          <p:cNvPr id="9" name="Text 6"/>
+          <p:cNvSpPr/>
+          <p:nvPr/>
+        </p:nvSpPr>
+        <p:spPr>
+          <a:xfrm>
+            <a:off x="1691640" y="1572768"/>
+            <a:ext cx="9646920" cy="384048"/>
+          </a:xfrm>
+          <a:prstGeom prst="rect">
+            <a:avLst/>
+          </a:prstGeom>
+          <a:noFill/>
+          <a:ln/>
+        </p:spPr>
+        <p:txBody>
+          <a:bodyPr wrap="square" lIns="0" tIns="0" rIns="0" bIns="0" rtlCol="0" anchor="ctr"/>
+          <a:lstStyle/>
+          <a:p>
+            <a:pPr indent="0" marL="0">
+              <a:buNone/>
+            </a:pPr>
+            <a:r>
+              <a:rPr lang="en-US" sz="1350" dirty="0">
+                <a:solidFill>
+                  <a:srgbClr val="424A5C"/>
+                </a:solidFill>
+                <a:latin typeface="Calibri" pitchFamily="34" charset="0"/>
+                <a:ea typeface="Calibri" pitchFamily="34" charset="-122"/>
+                <a:cs typeface="Calibri" pitchFamily="34" charset="-120"/>
+              </a:rPr>
+              <a:t>Base-R low-level graphics system (Paul Murrell) underlying ggplot2, lattice, gridExtra and gridBase.</a:t>
+            </a:r>
+            <a:endParaRPr lang="en-US" sz="1350" dirty="0"/>
+          </a:p>
+        </p:txBody>
+      </p:sp>
+      <p:sp>
+        <p:nvSpPr>
+          <p:cNvPr id="10" name="Text 7"/>
+          <p:cNvSpPr/>
+          <p:nvPr/>
+        </p:nvSpPr>
+        <p:spPr>
+          <a:xfrm>
+            <a:off x="859536" y="2029968"/>
+            <a:ext cx="10442448" cy="1005840"/>
+          </a:xfrm>
+          <a:prstGeom prst="rect">
+            <a:avLst/>
+          </a:prstGeom>
+          <a:noFill/>
+          <a:ln/>
+        </p:spPr>
+        <p:txBody>
+          <a:bodyPr wrap="square" lIns="0" tIns="0" rIns="0" bIns="0" rtlCol="0" anchor="t"/>
+          <a:lstStyle/>
+          <a:p>
+            <a:pPr indent="0" marL="0">
+              <a:spcAft>
+                <a:spcPts val="400"/>
+              </a:spcAft>
+              <a:buNone/>
+            </a:pPr>
+            <a:r>
+              <a:rPr lang="en-US" sz="1200" u="sng" dirty="0">
+                <a:solidFill>
+                  <a:srgbClr val="3B4A8C"/>
+                </a:solidFill>
+                <a:latin typeface="Calibri" pitchFamily="34" charset="0"/>
+                <a:ea typeface="Calibri" pitchFamily="34" charset="-122"/>
+                <a:cs typeface="Calibri" pitchFamily="34" charset="-120"/>
+                <a:hlinkClick r:id="rId2" invalidUrl="" action="" tgtFrame="" tooltip="" history="1" highlightClick="0" endSnd="0">
+                  <a:extLst>
+                    <a:ext uri="{A12FA001-AC4F-418D-AE19-62706E023703}">
+                      <ahyp:hlinkClr xmlns:ahyp="http://schemas.microsoft.com/office/drawing/2018/hyperlinkcolor" val="tx"/>
+                    </a:ext>
+                  </a:extLst>
+                </a:hlinkClick>
+              </a:rPr>
+              <a:t>Function index: stat.ethz.ch/R-manual/R-devel/library/grid/html/00Index.html</a:t>
+            </a:r>
+            <a:endParaRPr lang="en-US" sz="1200" dirty="0"/>
+          </a:p>
+          <a:p>
+            <a:pPr indent="0" marL="0">
+              <a:spcAft>
+                <a:spcPts val="400"/>
+              </a:spcAft>
+              <a:buNone/>
+            </a:pPr>
+            <a:r>
+              <a:rPr lang="en-US" sz="1200" u="sng" dirty="0">
+                <a:solidFill>
+                  <a:srgbClr val="3B4A8C"/>
+                </a:solidFill>
+                <a:latin typeface="Calibri" pitchFamily="34" charset="0"/>
+                <a:ea typeface="Calibri" pitchFamily="34" charset="-122"/>
+                <a:cs typeface="Calibri" pitchFamily="34" charset="-120"/>
+                <a:hlinkClick r:id="rId3" invalidUrl="" action="" tgtFrame="" tooltip="" history="1" highlightClick="0" endSnd="0">
+                  <a:extLst>
+                    <a:ext uri="{A12FA001-AC4F-418D-AE19-62706E023703}">
+                      <ahyp:hlinkClr xmlns:ahyp="http://schemas.microsoft.com/office/drawing/2018/hyperlinkcolor" val="tx"/>
+                    </a:ext>
+                  </a:extLst>
+                </a:hlinkClick>
+              </a:rPr>
+              <a:t>Paul Murrell, R Graphics (3rd ed., 2018), CRC Press: stat.auckland.ac.nz/~paul/RG3e/</a:t>
+            </a:r>
+            <a:endParaRPr lang="en-US" sz="1200" dirty="0"/>
+          </a:p>
+          <a:p>
+            <a:pPr indent="0" marL="0">
+              <a:spcAft>
+                <a:spcPts val="400"/>
+              </a:spcAft>
+              <a:buNone/>
+            </a:pPr>
+            <a:r>
+              <a:rPr lang="en-US" sz="1200" u="sng" dirty="0">
+                <a:solidFill>
+                  <a:srgbClr val="3B4A8C"/>
+                </a:solidFill>
+                <a:latin typeface="Calibri" pitchFamily="34" charset="0"/>
+                <a:ea typeface="Calibri" pitchFamily="34" charset="-122"/>
+                <a:cs typeface="Calibri" pitchFamily="34" charset="-120"/>
+                <a:hlinkClick r:id="rId4" invalidUrl="" action="" tgtFrame="" tooltip="" history="1" highlightClick="0" endSnd="0">
+                  <a:extLst>
+                    <a:ext uri="{A12FA001-AC4F-418D-AE19-62706E023703}">
+                      <ahyp:hlinkClr xmlns:ahyp="http://schemas.microsoft.com/office/drawing/2018/hyperlinkcolor" val="tx"/>
+                    </a:ext>
+                  </a:extLst>
+                </a:hlinkClick>
+              </a:rPr>
+              <a:t>Introduction to grid (PDF): stat.auckland.ac.nz/~paul/RGraphics/chapter5.pdf</a:t>
+            </a:r>
+            <a:endParaRPr lang="en-US" sz="1200" dirty="0"/>
+          </a:p>
+        </p:txBody>
+      </p:sp>
+      <p:sp>
+        <p:nvSpPr>
+          <p:cNvPr id="11" name="Shape 8"/>
+          <p:cNvSpPr/>
+          <p:nvPr/>
+        </p:nvSpPr>
+        <p:spPr>
+          <a:xfrm>
+            <a:off x="548640" y="3246120"/>
+            <a:ext cx="11064240" cy="1143000"/>
+          </a:xfrm>
+          <a:prstGeom prst="roundRect">
+            <a:avLst>
+              <a:gd name="adj" fmla="val 7200"/>
+            </a:avLst>
+          </a:prstGeom>
+          <a:solidFill>
+            <a:srgbClr val="E7F4F1"/>
+          </a:solidFill>
+          <a:ln/>
+          <a:effectLst>
+            <a:outerShdw sx="100000" sy="100000" kx="0" ky="0" algn="bl" rotWithShape="0" blurRad="88900" dist="38100" dir="5400000">
+              <a:srgbClr val="000000">
+                <a:alpha val="12000"/>
+              </a:srgbClr>
+            </a:outerShdw>
+          </a:effectLst>
+        </p:spPr>
+      </p:sp>
+      <p:sp>
+        <p:nvSpPr>
+          <p:cNvPr id="12" name="Shape 9"/>
+          <p:cNvSpPr/>
+          <p:nvPr/>
+        </p:nvSpPr>
+        <p:spPr>
+          <a:xfrm>
+            <a:off x="822960" y="3447288"/>
+            <a:ext cx="1120140" cy="384048"/>
+          </a:xfrm>
+          <a:prstGeom prst="roundRect">
+            <a:avLst>
+              <a:gd name="adj" fmla="val 50000"/>
+            </a:avLst>
+          </a:prstGeom>
+          <a:solidFill>
+            <a:srgbClr val="0E8C7F"/>
+          </a:solidFill>
+          <a:ln/>
+        </p:spPr>
+      </p:sp>
+      <p:sp>
+        <p:nvSpPr>
+          <p:cNvPr id="13" name="Text 10"/>
+          <p:cNvSpPr/>
+          <p:nvPr/>
+        </p:nvSpPr>
+        <p:spPr>
+          <a:xfrm>
+            <a:off x="822960" y="3447288"/>
+            <a:ext cx="1120140" cy="384048"/>
+          </a:xfrm>
+          <a:prstGeom prst="rect">
+            <a:avLst/>
+          </a:prstGeom>
+          <a:noFill/>
+          <a:ln/>
+        </p:spPr>
+        <p:txBody>
+          <a:bodyPr wrap="square" lIns="0" tIns="0" rIns="0" bIns="0" rtlCol="0" anchor="ctr"/>
+          <a:lstStyle/>
+          <a:p>
+            <a:pPr algn="ctr" indent="0" marL="0">
+              <a:buNone/>
+            </a:pPr>
+            <a:r>
+              <a:rPr lang="en-US" sz="1300" b="1" dirty="0">
+                <a:solidFill>
+                  <a:srgbClr val="FFFFFF"/>
+                </a:solidFill>
+                <a:latin typeface="Courier New" pitchFamily="34" charset="0"/>
+                <a:ea typeface="Courier New" pitchFamily="34" charset="-122"/>
+                <a:cs typeface="Courier New" pitchFamily="34" charset="-120"/>
+              </a:rPr>
+              <a:t>gridExtra</a:t>
+            </a:r>
+            <a:endParaRPr lang="en-US" sz="1300" dirty="0"/>
+          </a:p>
+        </p:txBody>
+      </p:sp>
+      <p:sp>
+        <p:nvSpPr>
+          <p:cNvPr id="14" name="Text 11"/>
+          <p:cNvSpPr/>
+          <p:nvPr/>
+        </p:nvSpPr>
+        <p:spPr>
+          <a:xfrm>
+            <a:off x="2171700" y="3447288"/>
+            <a:ext cx="9166860" cy="384048"/>
+          </a:xfrm>
+          <a:prstGeom prst="rect">
+            <a:avLst/>
+          </a:prstGeom>
+          <a:noFill/>
+          <a:ln/>
+        </p:spPr>
+        <p:txBody>
+          <a:bodyPr wrap="square" lIns="0" tIns="0" rIns="0" bIns="0" rtlCol="0" anchor="ctr"/>
+          <a:lstStyle/>
+          <a:p>
+            <a:pPr indent="0" marL="0">
+              <a:buNone/>
+            </a:pPr>
+            <a:r>
+              <a:rPr lang="en-US" sz="1350" dirty="0">
+                <a:solidFill>
+                  <a:srgbClr val="424A5C"/>
+                </a:solidFill>
+                <a:latin typeface="Calibri" pitchFamily="34" charset="0"/>
+                <a:ea typeface="Calibri" pitchFamily="34" charset="-122"/>
+                <a:cs typeface="Calibri" pitchFamily="34" charset="-120"/>
+              </a:rPr>
+              <a:t>Arrange multiple grid / ggplot plots on a page and draw tables (Baptiste Auguie, v2.3).</a:t>
+            </a:r>
+            <a:endParaRPr lang="en-US" sz="1350" dirty="0"/>
+          </a:p>
+        </p:txBody>
+      </p:sp>
+      <p:sp>
+        <p:nvSpPr>
+          <p:cNvPr id="15" name="Text 12"/>
+          <p:cNvSpPr/>
+          <p:nvPr/>
+        </p:nvSpPr>
+        <p:spPr>
+          <a:xfrm>
+            <a:off x="859536" y="3904488"/>
+            <a:ext cx="10442448" cy="365760"/>
+          </a:xfrm>
+          <a:prstGeom prst="rect">
+            <a:avLst/>
+          </a:prstGeom>
+          <a:noFill/>
+          <a:ln/>
+        </p:spPr>
+        <p:txBody>
+          <a:bodyPr wrap="square" lIns="0" tIns="0" rIns="0" bIns="0" rtlCol="0" anchor="t"/>
+          <a:lstStyle/>
+          <a:p>
+            <a:pPr indent="0" marL="0">
+              <a:spcAft>
+                <a:spcPts val="400"/>
+              </a:spcAft>
+              <a:buNone/>
+            </a:pPr>
+            <a:r>
+              <a:rPr lang="en-US" sz="1200" u="sng" dirty="0">
+                <a:solidFill>
+                  <a:srgbClr val="3B4A8C"/>
+                </a:solidFill>
+                <a:latin typeface="Calibri" pitchFamily="34" charset="0"/>
+                <a:ea typeface="Calibri" pitchFamily="34" charset="-122"/>
+                <a:cs typeface="Calibri" pitchFamily="34" charset="-120"/>
+                <a:hlinkClick r:id="rId5" invalidUrl="" action="" tgtFrame="" tooltip="" history="1" highlightClick="0" endSnd="0">
+                  <a:extLst>
+                    <a:ext uri="{A12FA001-AC4F-418D-AE19-62706E023703}">
+                      <ahyp:hlinkClr xmlns:ahyp="http://schemas.microsoft.com/office/drawing/2018/hyperlinkcolor" val="tx"/>
+                    </a:ext>
+                  </a:extLst>
+                </a:hlinkClick>
+              </a:rPr>
+              <a:t>CRAN: CRAN.R-project.org/package=gridExtra</a:t>
+            </a:r>
+            <a:endParaRPr lang="en-US" sz="1200" dirty="0"/>
+          </a:p>
+        </p:txBody>
+      </p:sp>
+      <p:sp>
+        <p:nvSpPr>
+          <p:cNvPr id="16" name="Shape 13"/>
+          <p:cNvSpPr/>
+          <p:nvPr/>
+        </p:nvSpPr>
+        <p:spPr>
+          <a:xfrm>
+            <a:off x="548640" y="4480560"/>
+            <a:ext cx="11064240" cy="1737360"/>
+          </a:xfrm>
+          <a:prstGeom prst="roundRect">
+            <a:avLst>
+              <a:gd name="adj" fmla="val 4737"/>
+            </a:avLst>
+          </a:prstGeom>
+          <a:solidFill>
+            <a:srgbClr val="EDEFF8"/>
+          </a:solidFill>
+          <a:ln/>
+          <a:effectLst>
+            <a:outerShdw sx="100000" sy="100000" kx="0" ky="0" algn="bl" rotWithShape="0" blurRad="88900" dist="38100" dir="5400000">
+              <a:srgbClr val="000000">
+                <a:alpha val="12000"/>
+              </a:srgbClr>
+            </a:outerShdw>
+          </a:effectLst>
+        </p:spPr>
+      </p:sp>
+      <p:sp>
+        <p:nvSpPr>
+          <p:cNvPr id="17" name="Shape 14"/>
+          <p:cNvSpPr/>
+          <p:nvPr/>
+        </p:nvSpPr>
+        <p:spPr>
+          <a:xfrm>
+            <a:off x="822960" y="4681728"/>
+            <a:ext cx="1024128" cy="384048"/>
+          </a:xfrm>
+          <a:prstGeom prst="roundRect">
+            <a:avLst>
+              <a:gd name="adj" fmla="val 50000"/>
+            </a:avLst>
+          </a:prstGeom>
+          <a:solidFill>
+            <a:srgbClr val="3B4A8C"/>
+          </a:solidFill>
+          <a:ln/>
+        </p:spPr>
+      </p:sp>
+      <p:sp>
+        <p:nvSpPr>
+          <p:cNvPr id="18" name="Text 15"/>
+          <p:cNvSpPr/>
+          <p:nvPr/>
+        </p:nvSpPr>
+        <p:spPr>
+          <a:xfrm>
+            <a:off x="822960" y="4681728"/>
+            <a:ext cx="1024128" cy="384048"/>
+          </a:xfrm>
+          <a:prstGeom prst="rect">
+            <a:avLst/>
+          </a:prstGeom>
+          <a:noFill/>
+          <a:ln/>
+        </p:spPr>
+        <p:txBody>
+          <a:bodyPr wrap="square" lIns="0" tIns="0" rIns="0" bIns="0" rtlCol="0" anchor="ctr"/>
+          <a:lstStyle/>
+          <a:p>
+            <a:pPr algn="ctr" indent="0" marL="0">
+              <a:buNone/>
+            </a:pPr>
+            <a:r>
+              <a:rPr lang="en-US" sz="1300" b="1" dirty="0">
+                <a:solidFill>
+                  <a:srgbClr val="FFFFFF"/>
+                </a:solidFill>
+                <a:latin typeface="Courier New" pitchFamily="34" charset="0"/>
+                <a:ea typeface="Courier New" pitchFamily="34" charset="-122"/>
+                <a:cs typeface="Courier New" pitchFamily="34" charset="-120"/>
+              </a:rPr>
+              <a:t>gridBase</a:t>
+            </a:r>
+            <a:endParaRPr lang="en-US" sz="1300" dirty="0"/>
+          </a:p>
+        </p:txBody>
+      </p:sp>
+      <p:sp>
+        <p:nvSpPr>
+          <p:cNvPr id="19" name="Text 16"/>
+          <p:cNvSpPr/>
+          <p:nvPr/>
+        </p:nvSpPr>
+        <p:spPr>
+          <a:xfrm>
+            <a:off x="2075688" y="4681728"/>
+            <a:ext cx="9262872" cy="384048"/>
+          </a:xfrm>
+          <a:prstGeom prst="rect">
+            <a:avLst/>
+          </a:prstGeom>
+          <a:noFill/>
+          <a:ln/>
+        </p:spPr>
+        <p:txBody>
+          <a:bodyPr wrap="square" lIns="0" tIns="0" rIns="0" bIns="0" rtlCol="0" anchor="ctr"/>
+          <a:lstStyle/>
+          <a:p>
+            <a:pPr indent="0" marL="0">
+              <a:buNone/>
+            </a:pPr>
+            <a:r>
+              <a:rPr lang="en-US" sz="1350" dirty="0">
+                <a:solidFill>
+                  <a:srgbClr val="424A5C"/>
+                </a:solidFill>
+                <a:latin typeface="Calibri" pitchFamily="34" charset="0"/>
+                <a:ea typeface="Calibri" pitchFamily="34" charset="-122"/>
+                <a:cs typeface="Calibri" pitchFamily="34" charset="-120"/>
+              </a:rPr>
+              <a:t>Integrate base and grid graphics on one page (Paul Murrell, v0.4-7).</a:t>
+            </a:r>
+            <a:endParaRPr lang="en-US" sz="1350" dirty="0"/>
+          </a:p>
+        </p:txBody>
+      </p:sp>
+      <p:sp>
+        <p:nvSpPr>
+          <p:cNvPr id="20" name="Text 17"/>
+          <p:cNvSpPr/>
+          <p:nvPr/>
+        </p:nvSpPr>
+        <p:spPr>
+          <a:xfrm>
+            <a:off x="859536" y="5138928"/>
+            <a:ext cx="10442448" cy="960120"/>
+          </a:xfrm>
+          <a:prstGeom prst="rect">
+            <a:avLst/>
+          </a:prstGeom>
+          <a:noFill/>
+          <a:ln/>
+        </p:spPr>
+        <p:txBody>
+          <a:bodyPr wrap="square" lIns="0" tIns="0" rIns="0" bIns="0" rtlCol="0" anchor="t"/>
+          <a:lstStyle/>
+          <a:p>
+            <a:pPr indent="0" marL="0">
+              <a:spcAft>
+                <a:spcPts val="400"/>
+              </a:spcAft>
+              <a:buNone/>
+            </a:pPr>
+            <a:r>
+              <a:rPr lang="en-US" sz="1200" u="sng" dirty="0">
+                <a:solidFill>
+                  <a:srgbClr val="3B4A8C"/>
+                </a:solidFill>
+                <a:latin typeface="Calibri" pitchFamily="34" charset="0"/>
+                <a:ea typeface="Calibri" pitchFamily="34" charset="-122"/>
+                <a:cs typeface="Calibri" pitchFamily="34" charset="-120"/>
+                <a:hlinkClick r:id="rId6" invalidUrl="" action="" tgtFrame="" tooltip="" history="1" highlightClick="0" endSnd="0">
+                  <a:extLst>
+                    <a:ext uri="{A12FA001-AC4F-418D-AE19-62706E023703}">
+                      <ahyp:hlinkClr xmlns:ahyp="http://schemas.microsoft.com/office/drawing/2018/hyperlinkcolor" val="tx"/>
+                    </a:ext>
+                  </a:extLst>
+                </a:hlinkClick>
+              </a:rPr>
+              <a:t>CRAN: CRAN.R-project.org/package=gridBase</a:t>
+            </a:r>
+            <a:endParaRPr lang="en-US" sz="1200" dirty="0"/>
+          </a:p>
+          <a:p>
+            <a:pPr indent="0" marL="0">
+              <a:spcAft>
+                <a:spcPts val="400"/>
+              </a:spcAft>
+              <a:buNone/>
+            </a:pPr>
+            <a:r>
+              <a:rPr lang="en-US" sz="1200" u="sng" dirty="0">
+                <a:solidFill>
+                  <a:srgbClr val="3B4A8C"/>
+                </a:solidFill>
+                <a:latin typeface="Calibri" pitchFamily="34" charset="0"/>
+                <a:ea typeface="Calibri" pitchFamily="34" charset="-122"/>
+                <a:cs typeface="Calibri" pitchFamily="34" charset="-120"/>
+                <a:hlinkClick r:id="rId7" invalidUrl="" action="" tgtFrame="" tooltip="" history="1" highlightClick="0" endSnd="0">
+                  <a:extLst>
+                    <a:ext uri="{A12FA001-AC4F-418D-AE19-62706E023703}">
+                      <ahyp:hlinkClr xmlns:ahyp="http://schemas.microsoft.com/office/drawing/2018/hyperlinkcolor" val="tx"/>
+                    </a:ext>
+                  </a:extLst>
+                </a:hlinkClick>
+              </a:rPr>
+              <a:t>Paul Murrell, "The gridBase Package", R News 3(2), 2003 (PDF): cran.r-project.org/doc/Rnews/Rnews_2003-2.pdf</a:t>
+            </a:r>
+            <a:endParaRPr lang="en-US" sz="1200" dirty="0"/>
+          </a:p>
+        </p:txBody>
+      </p:sp>
+    </p:spTree>
+  </p:cSld>
+  <p:clrMapOvr>
+    <a:masterClrMapping/>
+  </p:clrMapOvr>
+</p:sld>
+</file>
+
 <file path=ppt/theme/theme1.xml><?xml version="1.0" encoding="utf-8"?>
 <a:theme xmlns:a="http://schemas.openxmlformats.org/drawingml/2006/main" name="Office Theme">
   <a:themeElements>

</xml_diff>